<commit_message>
Update PowerFX embedding session.pptx
</commit_message>
<xml_diff>
--- a/src-powerfx/slides/PowerFX embedding session.pptx
+++ b/src-powerfx/slides/PowerFX embedding session.pptx
@@ -5,7 +5,7 @@
     <p:sldMasterId id="2147483648" r:id="rId1"/>
   </p:sldMasterIdLst>
   <p:notesMasterIdLst>
-    <p:notesMasterId r:id="rId19"/>
+    <p:notesMasterId r:id="rId20"/>
   </p:notesMasterIdLst>
   <p:sldIdLst>
     <p:sldId id="256" r:id="rId2"/>
@@ -17,14 +17,15 @@
     <p:sldId id="267" r:id="rId8"/>
     <p:sldId id="268" r:id="rId9"/>
     <p:sldId id="265" r:id="rId10"/>
-    <p:sldId id="260" r:id="rId11"/>
-    <p:sldId id="259" r:id="rId12"/>
-    <p:sldId id="261" r:id="rId13"/>
-    <p:sldId id="262" r:id="rId14"/>
-    <p:sldId id="269" r:id="rId15"/>
-    <p:sldId id="270" r:id="rId16"/>
-    <p:sldId id="263" r:id="rId17"/>
-    <p:sldId id="264" r:id="rId18"/>
+    <p:sldId id="274" r:id="rId11"/>
+    <p:sldId id="260" r:id="rId12"/>
+    <p:sldId id="259" r:id="rId13"/>
+    <p:sldId id="261" r:id="rId14"/>
+    <p:sldId id="262" r:id="rId15"/>
+    <p:sldId id="269" r:id="rId16"/>
+    <p:sldId id="270" r:id="rId17"/>
+    <p:sldId id="263" r:id="rId18"/>
+    <p:sldId id="264" r:id="rId19"/>
   </p:sldIdLst>
   <p:sldSz cx="12192000" cy="6858000"/>
   <p:notesSz cx="6858000" cy="9144000"/>
@@ -3052,7 +3053,7 @@
           <a:p>
             <a:fld id="{23F0FD94-F7CE-4D08-B49E-5E530976B685}" type="datetimeFigureOut">
               <a:rPr lang="en-US" smtClean="0"/>
-              <a:t>3/4/2026</a:t>
+              <a:t>3/14/2026</a:t>
             </a:fld>
             <a:endParaRPr lang="en-US"/>
           </a:p>
@@ -3403,6 +3404,341 @@
 </p:notes>
 </file>
 
+<file path=ppt/notesSlides/notesSlide10.xml><?xml version="1.0" encoding="utf-8"?>
+<p:notes xmlns:a="http://schemas.openxmlformats.org/drawingml/2006/main" xmlns:r="http://schemas.openxmlformats.org/officeDocument/2006/relationships" xmlns:p="http://schemas.openxmlformats.org/presentationml/2006/main">
+  <p:cSld>
+    <p:spTree>
+      <p:nvGrpSpPr>
+        <p:cNvPr id="1" name="">
+          <a:extLst>
+            <a:ext uri="{FF2B5EF4-FFF2-40B4-BE49-F238E27FC236}">
+              <a16:creationId xmlns:a16="http://schemas.microsoft.com/office/drawing/2014/main" id="{05160A75-DE7F-8BA4-1B80-65F17782ECEC}"/>
+            </a:ext>
+          </a:extLst>
+        </p:cNvPr>
+        <p:cNvGrpSpPr/>
+        <p:nvPr/>
+      </p:nvGrpSpPr>
+      <p:grpSpPr>
+        <a:xfrm>
+          <a:off x="0" y="0"/>
+          <a:ext cx="0" cy="0"/>
+          <a:chOff x="0" y="0"/>
+          <a:chExt cx="0" cy="0"/>
+        </a:xfrm>
+      </p:grpSpPr>
+      <p:sp>
+        <p:nvSpPr>
+          <p:cNvPr id="2" name="Slide Image Placeholder 1">
+            <a:extLst>
+              <a:ext uri="{FF2B5EF4-FFF2-40B4-BE49-F238E27FC236}">
+                <a16:creationId xmlns:a16="http://schemas.microsoft.com/office/drawing/2014/main" id="{17409352-9094-52B0-E533-973BBF225428}"/>
+              </a:ext>
+            </a:extLst>
+          </p:cNvPr>
+          <p:cNvSpPr>
+            <a:spLocks noGrp="1" noRot="1" noChangeAspect="1"/>
+          </p:cNvSpPr>
+          <p:nvPr>
+            <p:ph type="sldImg"/>
+          </p:nvPr>
+        </p:nvSpPr>
+        <p:spPr/>
+      </p:sp>
+      <p:sp>
+        <p:nvSpPr>
+          <p:cNvPr id="3" name="Notes Placeholder 2">
+            <a:extLst>
+              <a:ext uri="{FF2B5EF4-FFF2-40B4-BE49-F238E27FC236}">
+                <a16:creationId xmlns:a16="http://schemas.microsoft.com/office/drawing/2014/main" id="{ABB55E6A-A0F3-8248-17AF-93C63FE906EF}"/>
+              </a:ext>
+            </a:extLst>
+          </p:cNvPr>
+          <p:cNvSpPr>
+            <a:spLocks noGrp="1"/>
+          </p:cNvSpPr>
+          <p:nvPr>
+            <p:ph type="body" idx="1"/>
+          </p:nvPr>
+        </p:nvSpPr>
+        <p:spPr/>
+        <p:txBody>
+          <a:bodyPr/>
+          <a:lstStyle/>
+          <a:p>
+            <a:r>
+              <a:rPr lang="en-US" dirty="0"/>
+              <a:t>Alexandria starts looking for tools that can assist the business units with coming with solutions to their needs. She finds many applications and </a:t>
+            </a:r>
+            <a:r>
+              <a:rPr lang="en-US" dirty="0" err="1"/>
+              <a:t>frmeworks</a:t>
+            </a:r>
+            <a:r>
+              <a:rPr lang="en-US" dirty="0"/>
+              <a:t> whose purpose is to define and execute business. </a:t>
+            </a:r>
+          </a:p>
+          <a:p>
+            <a:r>
+              <a:rPr lang="en-US" dirty="0"/>
+              <a:t>A lot of the software out there for business rules is actually pretty mature, with </a:t>
+            </a:r>
+            <a:r>
+              <a:rPr lang="en-US" dirty="0" err="1"/>
+              <a:t>frameowkrs</a:t>
+            </a:r>
+            <a:r>
+              <a:rPr lang="en-US" dirty="0"/>
+              <a:t> such as Drools, and Camunda’s DNN. However, as good as those tools are, they are not a good fit for her org because most of those tools are Java based and would require the business units to learn new paradigms and syntaxes.</a:t>
+            </a:r>
+          </a:p>
+          <a:p>
+            <a:r>
+              <a:rPr lang="en-US" dirty="0"/>
+              <a:t>Alexandria does find that Microsoft has an Open Source engine for </a:t>
+            </a:r>
+            <a:r>
+              <a:rPr lang="en-US" dirty="0" err="1"/>
+              <a:t>.net</a:t>
+            </a:r>
+            <a:r>
+              <a:rPr lang="en-US" dirty="0"/>
+              <a:t> for rules. Even though this one is based in </a:t>
+            </a:r>
+            <a:r>
+              <a:rPr lang="en-US" dirty="0" err="1"/>
+              <a:t>.net</a:t>
+            </a:r>
+            <a:r>
+              <a:rPr lang="en-US" dirty="0"/>
+              <a:t>, the syntax is still a little bit unfamiliar to the business.</a:t>
+            </a:r>
+          </a:p>
+          <a:p>
+            <a:r>
+              <a:rPr lang="en-US" dirty="0"/>
+              <a:t>Another approach she finds is using Windows Workflows as a business friendly to define business logic.</a:t>
+            </a:r>
+          </a:p>
+        </p:txBody>
+      </p:sp>
+      <p:sp>
+        <p:nvSpPr>
+          <p:cNvPr id="4" name="Slide Number Placeholder 3">
+            <a:extLst>
+              <a:ext uri="{FF2B5EF4-FFF2-40B4-BE49-F238E27FC236}">
+                <a16:creationId xmlns:a16="http://schemas.microsoft.com/office/drawing/2014/main" id="{647AB185-B3FD-D7E8-7409-C76A358FD8A2}"/>
+              </a:ext>
+            </a:extLst>
+          </p:cNvPr>
+          <p:cNvSpPr>
+            <a:spLocks noGrp="1"/>
+          </p:cNvSpPr>
+          <p:nvPr>
+            <p:ph type="sldNum" sz="quarter" idx="5"/>
+          </p:nvPr>
+        </p:nvSpPr>
+        <p:spPr/>
+        <p:txBody>
+          <a:bodyPr/>
+          <a:lstStyle/>
+          <a:p>
+            <a:fld id="{A3FADD39-AB8A-4278-99D9-40CD8D745BA1}" type="slidenum">
+              <a:rPr lang="en-US" smtClean="0"/>
+              <a:t>10</a:t>
+            </a:fld>
+            <a:endParaRPr lang="en-US"/>
+          </a:p>
+        </p:txBody>
+      </p:sp>
+    </p:spTree>
+    <p:extLst>
+      <p:ext uri="{BB962C8B-B14F-4D97-AF65-F5344CB8AC3E}">
+        <p14:creationId xmlns:p14="http://schemas.microsoft.com/office/powerpoint/2010/main" val="2983418390"/>
+      </p:ext>
+    </p:extLst>
+  </p:cSld>
+  <p:clrMapOvr>
+    <a:masterClrMapping/>
+  </p:clrMapOvr>
+</p:notes>
+</file>
+
+<file path=ppt/notesSlides/notesSlide11.xml><?xml version="1.0" encoding="utf-8"?>
+<p:notes xmlns:a="http://schemas.openxmlformats.org/drawingml/2006/main" xmlns:r="http://schemas.openxmlformats.org/officeDocument/2006/relationships" xmlns:p="http://schemas.openxmlformats.org/presentationml/2006/main">
+  <p:cSld>
+    <p:spTree>
+      <p:nvGrpSpPr>
+        <p:cNvPr id="1" name=""/>
+        <p:cNvGrpSpPr/>
+        <p:nvPr/>
+      </p:nvGrpSpPr>
+      <p:grpSpPr>
+        <a:xfrm>
+          <a:off x="0" y="0"/>
+          <a:ext cx="0" cy="0"/>
+          <a:chOff x="0" y="0"/>
+          <a:chExt cx="0" cy="0"/>
+        </a:xfrm>
+      </p:grpSpPr>
+      <p:sp>
+        <p:nvSpPr>
+          <p:cNvPr id="2" name="Slide Image Placeholder 1"/>
+          <p:cNvSpPr>
+            <a:spLocks noGrp="1" noRot="1" noChangeAspect="1"/>
+          </p:cNvSpPr>
+          <p:nvPr>
+            <p:ph type="sldImg"/>
+          </p:nvPr>
+        </p:nvSpPr>
+        <p:spPr/>
+      </p:sp>
+      <p:sp>
+        <p:nvSpPr>
+          <p:cNvPr id="3" name="Notes Placeholder 2"/>
+          <p:cNvSpPr>
+            <a:spLocks noGrp="1"/>
+          </p:cNvSpPr>
+          <p:nvPr>
+            <p:ph type="body" idx="1"/>
+          </p:nvPr>
+        </p:nvSpPr>
+        <p:spPr/>
+        <p:txBody>
+          <a:bodyPr/>
+          <a:lstStyle/>
+          <a:p>
+            <a:r>
+              <a:rPr lang="en-US" dirty="0"/>
+              <a:t>Now let’s talk about how this can be combined with .NET. Let’s first talk about “why”. As mentioned before, </a:t>
+            </a:r>
+            <a:r>
+              <a:rPr lang="en-US" dirty="0" err="1"/>
+              <a:t>PowerFx</a:t>
+            </a:r>
+            <a:r>
+              <a:rPr lang="en-US" dirty="0"/>
+              <a:t> has a </a:t>
+            </a:r>
+            <a:r>
+              <a:rPr lang="en-US" dirty="0" err="1"/>
+              <a:t>popuatr</a:t>
+            </a:r>
+            <a:r>
+              <a:rPr lang="en-US" dirty="0"/>
+              <a:t> </a:t>
+            </a:r>
+            <a:r>
+              <a:rPr lang="en-US" dirty="0" err="1"/>
+              <a:t>sytbnax</a:t>
+            </a:r>
+            <a:r>
+              <a:rPr lang="en-US" dirty="0"/>
+              <a:t> with other </a:t>
+            </a:r>
+            <a:r>
+              <a:rPr lang="en-US" dirty="0" err="1"/>
+              <a:t>Microsfot</a:t>
+            </a:r>
+            <a:r>
+              <a:rPr lang="en-US" dirty="0"/>
+              <a:t> Products out there using it. So the amount of existing knowledge out there makes existing answers available to those who use it. </a:t>
+            </a:r>
+          </a:p>
+          <a:p>
+            <a:endParaRPr lang="en-US" dirty="0"/>
+          </a:p>
+          <a:p>
+            <a:r>
+              <a:rPr lang="en-US" dirty="0"/>
+              <a:t>Adding it to </a:t>
+            </a:r>
+            <a:r>
+              <a:rPr lang="en-US" dirty="0" err="1"/>
+              <a:t>.net</a:t>
+            </a:r>
+            <a:r>
+              <a:rPr lang="en-US" dirty="0"/>
+              <a:t> will allow you to add logic without potentially having to recompile or redeploy your app because it is an interpreter engine. Although, in real world enterprise scenarios you would still want those </a:t>
+            </a:r>
+            <a:r>
+              <a:rPr lang="en-US" dirty="0" err="1"/>
+              <a:t>PowerFx</a:t>
+            </a:r>
+            <a:r>
+              <a:rPr lang="en-US" dirty="0"/>
+              <a:t> pieces to go through some sort of lower to upper environment </a:t>
+            </a:r>
+            <a:r>
+              <a:rPr lang="en-US" dirty="0" err="1"/>
+              <a:t>lifexyle</a:t>
+            </a:r>
+            <a:r>
+              <a:rPr lang="en-US" dirty="0"/>
+              <a:t>, although the </a:t>
+            </a:r>
+            <a:r>
+              <a:rPr lang="en-US" dirty="0" err="1"/>
+              <a:t>lifecyle</a:t>
+            </a:r>
+            <a:r>
+              <a:rPr lang="en-US" dirty="0"/>
+              <a:t> would be faster and not require a full re-deployment.</a:t>
+            </a:r>
+          </a:p>
+          <a:p>
+            <a:endParaRPr lang="en-US" dirty="0"/>
+          </a:p>
+          <a:p>
+            <a:r>
+              <a:rPr lang="en-US" dirty="0"/>
+              <a:t>The syntax of the language looks familiar to the business side if the business side is familiar </a:t>
+            </a:r>
+            <a:r>
+              <a:rPr lang="en-US"/>
+              <a:t>with Excel.</a:t>
+            </a:r>
+            <a:endParaRPr lang="en-US" dirty="0"/>
+          </a:p>
+        </p:txBody>
+      </p:sp>
+      <p:sp>
+        <p:nvSpPr>
+          <p:cNvPr id="4" name="Slide Number Placeholder 3"/>
+          <p:cNvSpPr>
+            <a:spLocks noGrp="1"/>
+          </p:cNvSpPr>
+          <p:nvPr>
+            <p:ph type="sldNum" sz="quarter" idx="5"/>
+          </p:nvPr>
+        </p:nvSpPr>
+        <p:spPr/>
+        <p:txBody>
+          <a:bodyPr/>
+          <a:lstStyle/>
+          <a:p>
+            <a:fld id="{A3FADD39-AB8A-4278-99D9-40CD8D745BA1}" type="slidenum">
+              <a:rPr lang="en-US" smtClean="0"/>
+              <a:t>12</a:t>
+            </a:fld>
+            <a:endParaRPr lang="en-US"/>
+          </a:p>
+        </p:txBody>
+      </p:sp>
+    </p:spTree>
+    <p:extLst>
+      <p:ext uri="{BB962C8B-B14F-4D97-AF65-F5344CB8AC3E}">
+        <p14:creationId xmlns:p14="http://schemas.microsoft.com/office/powerpoint/2010/main" val="3640277052"/>
+      </p:ext>
+    </p:extLst>
+  </p:cSld>
+  <p:clrMapOvr>
+    <a:masterClrMapping/>
+  </p:clrMapOvr>
+</p:notes>
+</file>
+
 <file path=ppt/notesSlides/notesSlide2.xml><?xml version="1.0" encoding="utf-8"?>
 <p:notes xmlns:a="http://schemas.openxmlformats.org/drawingml/2006/main" xmlns:r="http://schemas.openxmlformats.org/officeDocument/2006/relationships" xmlns:p="http://schemas.openxmlformats.org/presentationml/2006/main">
   <p:cSld>
@@ -3996,15 +4332,7 @@
           <a:p>
             <a:r>
               <a:rPr lang="en-US" dirty="0"/>
-              <a:t>This logic is not the code you write in order to communicate with external dependencies. It is not the code you write to open a database connection, or drop a message in a queue, or send an email, or even call an HTTP service. It is the code that determine when those things happen and the contents of their payload. For example, the requirement is to notify a customer if their account has an </a:t>
-            </a:r>
-            <a:r>
-              <a:rPr lang="en-US" dirty="0" err="1"/>
-              <a:t>monthlky</a:t>
-            </a:r>
-            <a:r>
-              <a:rPr lang="en-US" dirty="0"/>
-              <a:t> average lower than the average of the previous 12 months. The business logic is the logic that determines the criteria (the average calculations) and the </a:t>
+              <a:t>This logic is not the code you write in order to communicate with external dependencies. It is not the code you write to open a database connection, or drop a message in a queue, or send an email, or even call an HTTP service. It is the code that determine when those things happen and the contents of their payload. For example, the requirement is to notify a customer if their account has an monthly average lower than the average of the previous 12 months. The business logic is the logic that determines the criteria (the average calculations) and the </a:t>
             </a:r>
             <a:r>
               <a:rPr lang="en-US" dirty="0" err="1"/>
@@ -4029,29 +4357,16 @@
           <a:p>
             <a:r>
               <a:rPr lang="en-US" dirty="0"/>
-              <a:t>By doing this separation, you are able to test the business logic in more reliable way since you are coding your logic with a explicit separation from your external dependencies. For example, it makes it easier to test that the verbiage of the email will be correct without having to actually send ay emails or fully faking an email service. It also reduces your integration to the </a:t>
-            </a:r>
-            <a:r>
-              <a:rPr lang="en-US"/>
-              <a:t>bare minimum.</a:t>
-            </a:r>
+              <a:t>By doing this separation, you are able to test the business logic in more reliable way since you are coding your logic with a explicit separation from your external dependencies. For example, it makes it easier to test that the verbiage of the email will be correct without having to actually send ay emails or fully faking an email service. It also reduces your integration to the bare minimum.</a:t>
+            </a:r>
+          </a:p>
+          <a:p>
             <a:endParaRPr lang="en-US" dirty="0"/>
           </a:p>
           <a:p>
-            <a:endParaRPr lang="en-US" dirty="0"/>
-          </a:p>
-          <a:p>
             <a:r>
               <a:rPr lang="en-US" dirty="0"/>
-              <a:t>Several </a:t>
-            </a:r>
-            <a:r>
-              <a:rPr lang="en-US" dirty="0" err="1"/>
-              <a:t>archictures</a:t>
-            </a:r>
-            <a:r>
-              <a:rPr lang="en-US" dirty="0"/>
-              <a:t> styles out there reinforce this notion, for example ports and adapters and the hexagon architecture. </a:t>
+              <a:t>Several architecture styles out there reinforce this notion, for example ports and adapters and the hexagon architecture. </a:t>
             </a:r>
           </a:p>
           <a:p>
@@ -4411,7 +4726,78 @@
           <a:bodyPr/>
           <a:lstStyle/>
           <a:p>
-            <a:endParaRPr lang="en-US"/>
+            <a:r>
+              <a:rPr lang="en-US" dirty="0" err="1"/>
+              <a:t>Accodign</a:t>
+            </a:r>
+            <a:r>
+              <a:rPr lang="en-US" dirty="0"/>
+              <a:t> to </a:t>
+            </a:r>
+            <a:r>
+              <a:rPr lang="en-US" dirty="0" err="1"/>
+              <a:t>micosoft</a:t>
+            </a:r>
+            <a:r>
+              <a:rPr lang="en-US" dirty="0"/>
+              <a:t> “</a:t>
+            </a:r>
+            <a:r>
+              <a:rPr lang="en-US" sz="1200" b="0" i="0" kern="1200" dirty="0">
+                <a:solidFill>
+                  <a:schemeClr val="tx1"/>
+                </a:solidFill>
+                <a:effectLst/>
+                <a:latin typeface="+mn-lt"/>
+                <a:ea typeface="+mn-ea"/>
+                <a:cs typeface="+mn-cs"/>
+              </a:rPr>
+              <a:t>It's a general-purpose, strong-typed, declarative, and functional programming language.” (</a:t>
+            </a:r>
+            <a:r>
+              <a:rPr lang="en-US" dirty="0">
+                <a:hlinkClick r:id="rId3"/>
+              </a:rPr>
+              <a:t>Microsoft Power </a:t>
+            </a:r>
+            <a:r>
+              <a:rPr lang="en-US" dirty="0" err="1">
+                <a:hlinkClick r:id="rId3"/>
+              </a:rPr>
+              <a:t>Fx</a:t>
+            </a:r>
+            <a:r>
+              <a:rPr lang="en-US" dirty="0">
+                <a:hlinkClick r:id="rId3"/>
+              </a:rPr>
+              <a:t> overview - Power Platform | Microsoft Learn</a:t>
+            </a:r>
+            <a:r>
+              <a:rPr lang="en-US" dirty="0"/>
+              <a:t>)</a:t>
+            </a:r>
+          </a:p>
+          <a:p>
+            <a:r>
+              <a:rPr lang="en-US" dirty="0"/>
+              <a:t>One of the design goals is to have people think of </a:t>
+            </a:r>
+            <a:r>
+              <a:rPr lang="en-US" dirty="0" err="1"/>
+              <a:t>PowerFX</a:t>
+            </a:r>
+            <a:r>
+              <a:rPr lang="en-US" dirty="0"/>
+              <a:t> as </a:t>
+            </a:r>
+            <a:r>
+              <a:rPr lang="en-US" dirty="0" err="1"/>
+              <a:t>spreadhseets</a:t>
+            </a:r>
+            <a:r>
+              <a:rPr lang="en-US" dirty="0"/>
+              <a:t> (https://learn.microsoft.com/en-us/power-platform/power-fx/overview#think-spreadsheet )</a:t>
+            </a:r>
           </a:p>
         </p:txBody>
       </p:sp>
@@ -4598,7 +4984,7 @@
           <a:p>
             <a:fld id="{5CDD294D-83BB-48C2-9EE9-4B0B0168A414}" type="datetimeFigureOut">
               <a:rPr lang="en-US" smtClean="0"/>
-              <a:t>3/4/2026</a:t>
+              <a:t>3/14/2026</a:t>
             </a:fld>
             <a:endParaRPr lang="en-US"/>
           </a:p>
@@ -4796,7 +5182,7 @@
           <a:p>
             <a:fld id="{5CDD294D-83BB-48C2-9EE9-4B0B0168A414}" type="datetimeFigureOut">
               <a:rPr lang="en-US" smtClean="0"/>
-              <a:t>3/4/2026</a:t>
+              <a:t>3/14/2026</a:t>
             </a:fld>
             <a:endParaRPr lang="en-US"/>
           </a:p>
@@ -5004,7 +5390,7 @@
           <a:p>
             <a:fld id="{5CDD294D-83BB-48C2-9EE9-4B0B0168A414}" type="datetimeFigureOut">
               <a:rPr lang="en-US" smtClean="0"/>
-              <a:t>3/4/2026</a:t>
+              <a:t>3/14/2026</a:t>
             </a:fld>
             <a:endParaRPr lang="en-US"/>
           </a:p>
@@ -5202,7 +5588,7 @@
           <a:p>
             <a:fld id="{5CDD294D-83BB-48C2-9EE9-4B0B0168A414}" type="datetimeFigureOut">
               <a:rPr lang="en-US" smtClean="0"/>
-              <a:t>3/4/2026</a:t>
+              <a:t>3/14/2026</a:t>
             </a:fld>
             <a:endParaRPr lang="en-US"/>
           </a:p>
@@ -5477,7 +5863,7 @@
           <a:p>
             <a:fld id="{5CDD294D-83BB-48C2-9EE9-4B0B0168A414}" type="datetimeFigureOut">
               <a:rPr lang="en-US" smtClean="0"/>
-              <a:t>3/4/2026</a:t>
+              <a:t>3/14/2026</a:t>
             </a:fld>
             <a:endParaRPr lang="en-US"/>
           </a:p>
@@ -5742,7 +6128,7 @@
           <a:p>
             <a:fld id="{5CDD294D-83BB-48C2-9EE9-4B0B0168A414}" type="datetimeFigureOut">
               <a:rPr lang="en-US" smtClean="0"/>
-              <a:t>3/4/2026</a:t>
+              <a:t>3/14/2026</a:t>
             </a:fld>
             <a:endParaRPr lang="en-US"/>
           </a:p>
@@ -6154,7 +6540,7 @@
           <a:p>
             <a:fld id="{5CDD294D-83BB-48C2-9EE9-4B0B0168A414}" type="datetimeFigureOut">
               <a:rPr lang="en-US" smtClean="0"/>
-              <a:t>3/4/2026</a:t>
+              <a:t>3/14/2026</a:t>
             </a:fld>
             <a:endParaRPr lang="en-US"/>
           </a:p>
@@ -6295,7 +6681,7 @@
           <a:p>
             <a:fld id="{5CDD294D-83BB-48C2-9EE9-4B0B0168A414}" type="datetimeFigureOut">
               <a:rPr lang="en-US" smtClean="0"/>
-              <a:t>3/4/2026</a:t>
+              <a:t>3/14/2026</a:t>
             </a:fld>
             <a:endParaRPr lang="en-US"/>
           </a:p>
@@ -6408,7 +6794,7 @@
           <a:p>
             <a:fld id="{5CDD294D-83BB-48C2-9EE9-4B0B0168A414}" type="datetimeFigureOut">
               <a:rPr lang="en-US" smtClean="0"/>
-              <a:t>3/4/2026</a:t>
+              <a:t>3/14/2026</a:t>
             </a:fld>
             <a:endParaRPr lang="en-US"/>
           </a:p>
@@ -6719,7 +7105,7 @@
           <a:p>
             <a:fld id="{5CDD294D-83BB-48C2-9EE9-4B0B0168A414}" type="datetimeFigureOut">
               <a:rPr lang="en-US" smtClean="0"/>
-              <a:t>3/4/2026</a:t>
+              <a:t>3/14/2026</a:t>
             </a:fld>
             <a:endParaRPr lang="en-US"/>
           </a:p>
@@ -7007,7 +7393,7 @@
           <a:p>
             <a:fld id="{5CDD294D-83BB-48C2-9EE9-4B0B0168A414}" type="datetimeFigureOut">
               <a:rPr lang="en-US" smtClean="0"/>
-              <a:t>3/4/2026</a:t>
+              <a:t>3/14/2026</a:t>
             </a:fld>
             <a:endParaRPr lang="en-US"/>
           </a:p>
@@ -7248,7 +7634,7 @@
           <a:p>
             <a:fld id="{5CDD294D-83BB-48C2-9EE9-4B0B0168A414}" type="datetimeFigureOut">
               <a:rPr lang="en-US" smtClean="0"/>
-              <a:t>3/4/2026</a:t>
+              <a:t>3/14/2026</a:t>
             </a:fld>
             <a:endParaRPr lang="en-US"/>
           </a:p>
@@ -8345,6 +8731,874 @@
 <file path=ppt/slides/slide10.xml><?xml version="1.0" encoding="utf-8"?>
 <p:sld xmlns:a="http://schemas.openxmlformats.org/drawingml/2006/main" xmlns:r="http://schemas.openxmlformats.org/officeDocument/2006/relationships" xmlns:p="http://schemas.openxmlformats.org/presentationml/2006/main">
   <p:cSld>
+    <p:bg>
+      <p:bgPr>
+        <a:solidFill>
+          <a:schemeClr val="bg1"/>
+        </a:solidFill>
+        <a:effectLst/>
+      </p:bgPr>
+    </p:bg>
+    <p:spTree>
+      <p:nvGrpSpPr>
+        <p:cNvPr id="1" name="">
+          <a:extLst>
+            <a:ext uri="{FF2B5EF4-FFF2-40B4-BE49-F238E27FC236}">
+              <a16:creationId xmlns:a16="http://schemas.microsoft.com/office/drawing/2014/main" id="{F6172307-19C0-3297-9326-EBBDE6DC0229}"/>
+            </a:ext>
+          </a:extLst>
+        </p:cNvPr>
+        <p:cNvGrpSpPr/>
+        <p:nvPr/>
+      </p:nvGrpSpPr>
+      <p:grpSpPr>
+        <a:xfrm>
+          <a:off x="0" y="0"/>
+          <a:ext cx="0" cy="0"/>
+          <a:chOff x="0" y="0"/>
+          <a:chExt cx="0" cy="0"/>
+        </a:xfrm>
+      </p:grpSpPr>
+      <p:sp useBgFill="1">
+        <p:nvSpPr>
+          <p:cNvPr id="8" name="Rectangle 7">
+            <a:extLst>
+              <a:ext uri="{FF2B5EF4-FFF2-40B4-BE49-F238E27FC236}">
+                <a16:creationId xmlns:a16="http://schemas.microsoft.com/office/drawing/2014/main" id="{A1D64FAC-9626-417E-B6DD-562060EC803C}"/>
+              </a:ext>
+              <a:ext uri="{C183D7F6-B498-43B3-948B-1728B52AA6E4}">
+                <adec:decorative xmlns:adec="http://schemas.microsoft.com/office/drawing/2017/decorative" val="1"/>
+              </a:ext>
+            </a:extLst>
+          </p:cNvPr>
+          <p:cNvSpPr>
+            <a:spLocks noGrp="1" noRot="1" noChangeAspect="1" noMove="1" noResize="1" noEditPoints="1" noAdjustHandles="1" noChangeArrowheads="1" noChangeShapeType="1" noTextEdit="1"/>
+          </p:cNvSpPr>
+          <p:nvPr>
+            <p:extLst>
+              <p:ext uri="{386F3935-93C4-4BCD-93E2-E3B085C9AB24}">
+                <p16:designElem xmlns:p16="http://schemas.microsoft.com/office/powerpoint/2015/main" val="1"/>
+              </p:ext>
+            </p:extLst>
+          </p:nvPr>
+        </p:nvSpPr>
+        <p:spPr>
+          <a:xfrm>
+            <a:off x="0" y="0"/>
+            <a:ext cx="12188952" cy="6858000"/>
+          </a:xfrm>
+          <a:prstGeom prst="rect">
+            <a:avLst/>
+          </a:prstGeom>
+          <a:ln>
+            <a:noFill/>
+          </a:ln>
+        </p:spPr>
+        <p:style>
+          <a:lnRef idx="2">
+            <a:schemeClr val="accent1">
+              <a:shade val="50000"/>
+            </a:schemeClr>
+          </a:lnRef>
+          <a:fillRef idx="1">
+            <a:schemeClr val="accent1"/>
+          </a:fillRef>
+          <a:effectRef idx="0">
+            <a:schemeClr val="accent1"/>
+          </a:effectRef>
+          <a:fontRef idx="minor">
+            <a:schemeClr val="lt1"/>
+          </a:fontRef>
+        </p:style>
+        <p:txBody>
+          <a:bodyPr rtlCol="0" anchor="ctr"/>
+          <a:lstStyle/>
+          <a:p>
+            <a:pPr algn="ctr"/>
+            <a:endParaRPr lang="en-US"/>
+          </a:p>
+        </p:txBody>
+      </p:sp>
+      <p:sp>
+        <p:nvSpPr>
+          <p:cNvPr id="2" name="Title 1">
+            <a:extLst>
+              <a:ext uri="{FF2B5EF4-FFF2-40B4-BE49-F238E27FC236}">
+                <a16:creationId xmlns:a16="http://schemas.microsoft.com/office/drawing/2014/main" id="{837EB793-6AB5-A5BF-4C68-B4DECD9CEBED}"/>
+              </a:ext>
+            </a:extLst>
+          </p:cNvPr>
+          <p:cNvSpPr>
+            <a:spLocks noGrp="1"/>
+          </p:cNvSpPr>
+          <p:nvPr>
+            <p:ph type="title"/>
+          </p:nvPr>
+        </p:nvSpPr>
+        <p:spPr>
+          <a:xfrm>
+            <a:off x="838200" y="365125"/>
+            <a:ext cx="10515600" cy="1325563"/>
+          </a:xfrm>
+        </p:spPr>
+        <p:txBody>
+          <a:bodyPr>
+            <a:normAutofit/>
+          </a:bodyPr>
+          <a:lstStyle/>
+          <a:p>
+            <a:r>
+              <a:rPr lang="en-US" sz="5400" dirty="0" err="1"/>
+              <a:t>PowerFx</a:t>
+            </a:r>
+            <a:endParaRPr lang="en-US" sz="5400" dirty="0"/>
+          </a:p>
+        </p:txBody>
+      </p:sp>
+      <p:sp>
+        <p:nvSpPr>
+          <p:cNvPr id="10" name="sketch line">
+            <a:extLst>
+              <a:ext uri="{FF2B5EF4-FFF2-40B4-BE49-F238E27FC236}">
+                <a16:creationId xmlns:a16="http://schemas.microsoft.com/office/drawing/2014/main" id="{D8BF7FBC-03BD-AF09-B726-4D60A72D3559}"/>
+              </a:ext>
+              <a:ext uri="{C183D7F6-B498-43B3-948B-1728B52AA6E4}">
+                <adec:decorative xmlns:adec="http://schemas.microsoft.com/office/drawing/2017/decorative" val="1"/>
+              </a:ext>
+            </a:extLst>
+          </p:cNvPr>
+          <p:cNvSpPr>
+            <a:spLocks noGrp="1" noRot="1" noChangeAspect="1" noMove="1" noResize="1" noEditPoints="1" noAdjustHandles="1" noChangeArrowheads="1" noChangeShapeType="1" noTextEdit="1"/>
+          </p:cNvSpPr>
+          <p:nvPr>
+            <p:extLst>
+              <p:ext uri="{386F3935-93C4-4BCD-93E2-E3B085C9AB24}">
+                <p16:designElem xmlns:p16="http://schemas.microsoft.com/office/powerpoint/2015/main" val="1"/>
+              </p:ext>
+            </p:extLst>
+          </p:nvPr>
+        </p:nvSpPr>
+        <p:spPr>
+          <a:xfrm>
+            <a:off x="669036" y="1677373"/>
+            <a:ext cx="10853928" cy="18288"/>
+          </a:xfrm>
+          <a:custGeom>
+            <a:avLst/>
+            <a:gdLst>
+              <a:gd name="csX0" fmla="*/ 0 w 10853928"/>
+              <a:gd name="csY0" fmla="*/ 0 h 18288"/>
+              <a:gd name="csX1" fmla="*/ 461292 w 10853928"/>
+              <a:gd name="csY1" fmla="*/ 0 h 18288"/>
+              <a:gd name="csX2" fmla="*/ 1139662 w 10853928"/>
+              <a:gd name="csY2" fmla="*/ 0 h 18288"/>
+              <a:gd name="csX3" fmla="*/ 1926572 w 10853928"/>
+              <a:gd name="csY3" fmla="*/ 0 h 18288"/>
+              <a:gd name="csX4" fmla="*/ 2279325 w 10853928"/>
+              <a:gd name="csY4" fmla="*/ 0 h 18288"/>
+              <a:gd name="csX5" fmla="*/ 2632078 w 10853928"/>
+              <a:gd name="csY5" fmla="*/ 0 h 18288"/>
+              <a:gd name="csX6" fmla="*/ 3527527 w 10853928"/>
+              <a:gd name="csY6" fmla="*/ 0 h 18288"/>
+              <a:gd name="csX7" fmla="*/ 4205897 w 10853928"/>
+              <a:gd name="csY7" fmla="*/ 0 h 18288"/>
+              <a:gd name="csX8" fmla="*/ 4558650 w 10853928"/>
+              <a:gd name="csY8" fmla="*/ 0 h 18288"/>
+              <a:gd name="csX9" fmla="*/ 5237020 w 10853928"/>
+              <a:gd name="csY9" fmla="*/ 0 h 18288"/>
+              <a:gd name="csX10" fmla="*/ 6132469 w 10853928"/>
+              <a:gd name="csY10" fmla="*/ 0 h 18288"/>
+              <a:gd name="csX11" fmla="*/ 6702301 w 10853928"/>
+              <a:gd name="csY11" fmla="*/ 0 h 18288"/>
+              <a:gd name="csX12" fmla="*/ 7272132 w 10853928"/>
+              <a:gd name="csY12" fmla="*/ 0 h 18288"/>
+              <a:gd name="csX13" fmla="*/ 7950502 w 10853928"/>
+              <a:gd name="csY13" fmla="*/ 0 h 18288"/>
+              <a:gd name="csX14" fmla="*/ 8737412 w 10853928"/>
+              <a:gd name="csY14" fmla="*/ 0 h 18288"/>
+              <a:gd name="csX15" fmla="*/ 9524322 w 10853928"/>
+              <a:gd name="csY15" fmla="*/ 0 h 18288"/>
+              <a:gd name="csX16" fmla="*/ 10853928 w 10853928"/>
+              <a:gd name="csY16" fmla="*/ 0 h 18288"/>
+              <a:gd name="csX17" fmla="*/ 10853928 w 10853928"/>
+              <a:gd name="csY17" fmla="*/ 18288 h 18288"/>
+              <a:gd name="csX18" fmla="*/ 10392636 w 10853928"/>
+              <a:gd name="csY18" fmla="*/ 18288 h 18288"/>
+              <a:gd name="csX19" fmla="*/ 9497187 w 10853928"/>
+              <a:gd name="csY19" fmla="*/ 18288 h 18288"/>
+              <a:gd name="csX20" fmla="*/ 8818817 w 10853928"/>
+              <a:gd name="csY20" fmla="*/ 18288 h 18288"/>
+              <a:gd name="csX21" fmla="*/ 8466064 w 10853928"/>
+              <a:gd name="csY21" fmla="*/ 18288 h 18288"/>
+              <a:gd name="csX22" fmla="*/ 7787693 w 10853928"/>
+              <a:gd name="csY22" fmla="*/ 18288 h 18288"/>
+              <a:gd name="csX23" fmla="*/ 7217862 w 10853928"/>
+              <a:gd name="csY23" fmla="*/ 18288 h 18288"/>
+              <a:gd name="csX24" fmla="*/ 6648031 w 10853928"/>
+              <a:gd name="csY24" fmla="*/ 18288 h 18288"/>
+              <a:gd name="csX25" fmla="*/ 6078200 w 10853928"/>
+              <a:gd name="csY25" fmla="*/ 18288 h 18288"/>
+              <a:gd name="csX26" fmla="*/ 5508368 w 10853928"/>
+              <a:gd name="csY26" fmla="*/ 18288 h 18288"/>
+              <a:gd name="csX27" fmla="*/ 4721459 w 10853928"/>
+              <a:gd name="csY27" fmla="*/ 18288 h 18288"/>
+              <a:gd name="csX28" fmla="*/ 4043088 w 10853928"/>
+              <a:gd name="csY28" fmla="*/ 18288 h 18288"/>
+              <a:gd name="csX29" fmla="*/ 3690336 w 10853928"/>
+              <a:gd name="csY29" fmla="*/ 18288 h 18288"/>
+              <a:gd name="csX30" fmla="*/ 3120504 w 10853928"/>
+              <a:gd name="csY30" fmla="*/ 18288 h 18288"/>
+              <a:gd name="csX31" fmla="*/ 2333595 w 10853928"/>
+              <a:gd name="csY31" fmla="*/ 18288 h 18288"/>
+              <a:gd name="csX32" fmla="*/ 1872303 w 10853928"/>
+              <a:gd name="csY32" fmla="*/ 18288 h 18288"/>
+              <a:gd name="csX33" fmla="*/ 976854 w 10853928"/>
+              <a:gd name="csY33" fmla="*/ 18288 h 18288"/>
+              <a:gd name="csX34" fmla="*/ 0 w 10853928"/>
+              <a:gd name="csY34" fmla="*/ 18288 h 18288"/>
+              <a:gd name="csX35" fmla="*/ 0 w 10853928"/>
+              <a:gd name="csY35" fmla="*/ 0 h 18288"/>
+            </a:gdLst>
+            <a:ahLst/>
+            <a:cxnLst>
+              <a:cxn ang="0">
+                <a:pos x="csX0" y="csY0"/>
+              </a:cxn>
+              <a:cxn ang="0">
+                <a:pos x="csX1" y="csY1"/>
+              </a:cxn>
+              <a:cxn ang="0">
+                <a:pos x="csX2" y="csY2"/>
+              </a:cxn>
+              <a:cxn ang="0">
+                <a:pos x="csX3" y="csY3"/>
+              </a:cxn>
+              <a:cxn ang="0">
+                <a:pos x="csX4" y="csY4"/>
+              </a:cxn>
+              <a:cxn ang="0">
+                <a:pos x="csX5" y="csY5"/>
+              </a:cxn>
+              <a:cxn ang="0">
+                <a:pos x="csX6" y="csY6"/>
+              </a:cxn>
+              <a:cxn ang="0">
+                <a:pos x="csX7" y="csY7"/>
+              </a:cxn>
+              <a:cxn ang="0">
+                <a:pos x="csX8" y="csY8"/>
+              </a:cxn>
+              <a:cxn ang="0">
+                <a:pos x="csX9" y="csY9"/>
+              </a:cxn>
+              <a:cxn ang="0">
+                <a:pos x="csX10" y="csY10"/>
+              </a:cxn>
+              <a:cxn ang="0">
+                <a:pos x="csX11" y="csY11"/>
+              </a:cxn>
+              <a:cxn ang="0">
+                <a:pos x="csX12" y="csY12"/>
+              </a:cxn>
+              <a:cxn ang="0">
+                <a:pos x="csX13" y="csY13"/>
+              </a:cxn>
+              <a:cxn ang="0">
+                <a:pos x="csX14" y="csY14"/>
+              </a:cxn>
+              <a:cxn ang="0">
+                <a:pos x="csX15" y="csY15"/>
+              </a:cxn>
+              <a:cxn ang="0">
+                <a:pos x="csX16" y="csY16"/>
+              </a:cxn>
+              <a:cxn ang="0">
+                <a:pos x="csX17" y="csY17"/>
+              </a:cxn>
+              <a:cxn ang="0">
+                <a:pos x="csX18" y="csY18"/>
+              </a:cxn>
+              <a:cxn ang="0">
+                <a:pos x="csX19" y="csY19"/>
+              </a:cxn>
+              <a:cxn ang="0">
+                <a:pos x="csX20" y="csY20"/>
+              </a:cxn>
+              <a:cxn ang="0">
+                <a:pos x="csX21" y="csY21"/>
+              </a:cxn>
+              <a:cxn ang="0">
+                <a:pos x="csX22" y="csY22"/>
+              </a:cxn>
+              <a:cxn ang="0">
+                <a:pos x="csX23" y="csY23"/>
+              </a:cxn>
+              <a:cxn ang="0">
+                <a:pos x="csX24" y="csY24"/>
+              </a:cxn>
+              <a:cxn ang="0">
+                <a:pos x="csX25" y="csY25"/>
+              </a:cxn>
+              <a:cxn ang="0">
+                <a:pos x="csX26" y="csY26"/>
+              </a:cxn>
+              <a:cxn ang="0">
+                <a:pos x="csX27" y="csY27"/>
+              </a:cxn>
+              <a:cxn ang="0">
+                <a:pos x="csX28" y="csY28"/>
+              </a:cxn>
+              <a:cxn ang="0">
+                <a:pos x="csX29" y="csY29"/>
+              </a:cxn>
+              <a:cxn ang="0">
+                <a:pos x="csX30" y="csY30"/>
+              </a:cxn>
+              <a:cxn ang="0">
+                <a:pos x="csX31" y="csY31"/>
+              </a:cxn>
+              <a:cxn ang="0">
+                <a:pos x="csX32" y="csY32"/>
+              </a:cxn>
+              <a:cxn ang="0">
+                <a:pos x="csX33" y="csY33"/>
+              </a:cxn>
+              <a:cxn ang="0">
+                <a:pos x="csX34" y="csY34"/>
+              </a:cxn>
+              <a:cxn ang="0">
+                <a:pos x="csX35" y="csY35"/>
+              </a:cxn>
+            </a:cxnLst>
+            <a:rect l="l" t="t" r="r" b="b"/>
+            <a:pathLst>
+              <a:path w="10853928" h="18288" fill="none" extrusionOk="0">
+                <a:moveTo>
+                  <a:pt x="0" y="0"/>
+                </a:moveTo>
+                <a:cubicBezTo>
+                  <a:pt x="146993" y="-19076"/>
+                  <a:pt x="347684" y="-4790"/>
+                  <a:pt x="461292" y="0"/>
+                </a:cubicBezTo>
+                <a:cubicBezTo>
+                  <a:pt x="574900" y="4790"/>
+                  <a:pt x="808367" y="19821"/>
+                  <a:pt x="1139662" y="0"/>
+                </a:cubicBezTo>
+                <a:cubicBezTo>
+                  <a:pt x="1470957" y="-19821"/>
+                  <a:pt x="1627405" y="5721"/>
+                  <a:pt x="1926572" y="0"/>
+                </a:cubicBezTo>
+                <a:cubicBezTo>
+                  <a:pt x="2225739" y="-5721"/>
+                  <a:pt x="2137730" y="-3235"/>
+                  <a:pt x="2279325" y="0"/>
+                </a:cubicBezTo>
+                <a:cubicBezTo>
+                  <a:pt x="2420920" y="3235"/>
+                  <a:pt x="2456518" y="9685"/>
+                  <a:pt x="2632078" y="0"/>
+                </a:cubicBezTo>
+                <a:cubicBezTo>
+                  <a:pt x="2807638" y="-9685"/>
+                  <a:pt x="3211516" y="-43007"/>
+                  <a:pt x="3527527" y="0"/>
+                </a:cubicBezTo>
+                <a:cubicBezTo>
+                  <a:pt x="3843538" y="43007"/>
+                  <a:pt x="4058833" y="22042"/>
+                  <a:pt x="4205897" y="0"/>
+                </a:cubicBezTo>
+                <a:cubicBezTo>
+                  <a:pt x="4352961" y="-22042"/>
+                  <a:pt x="4474805" y="-11846"/>
+                  <a:pt x="4558650" y="0"/>
+                </a:cubicBezTo>
+                <a:cubicBezTo>
+                  <a:pt x="4642495" y="11846"/>
+                  <a:pt x="5041928" y="-6069"/>
+                  <a:pt x="5237020" y="0"/>
+                </a:cubicBezTo>
+                <a:cubicBezTo>
+                  <a:pt x="5432112" y="6069"/>
+                  <a:pt x="5943266" y="-17479"/>
+                  <a:pt x="6132469" y="0"/>
+                </a:cubicBezTo>
+                <a:cubicBezTo>
+                  <a:pt x="6321672" y="17479"/>
+                  <a:pt x="6483872" y="26234"/>
+                  <a:pt x="6702301" y="0"/>
+                </a:cubicBezTo>
+                <a:cubicBezTo>
+                  <a:pt x="6920730" y="-26234"/>
+                  <a:pt x="6991194" y="-15156"/>
+                  <a:pt x="7272132" y="0"/>
+                </a:cubicBezTo>
+                <a:cubicBezTo>
+                  <a:pt x="7553070" y="15156"/>
+                  <a:pt x="7684444" y="-32961"/>
+                  <a:pt x="7950502" y="0"/>
+                </a:cubicBezTo>
+                <a:cubicBezTo>
+                  <a:pt x="8216560" y="32961"/>
+                  <a:pt x="8493290" y="-10491"/>
+                  <a:pt x="8737412" y="0"/>
+                </a:cubicBezTo>
+                <a:cubicBezTo>
+                  <a:pt x="8981534" y="10491"/>
+                  <a:pt x="9191586" y="-13899"/>
+                  <a:pt x="9524322" y="0"/>
+                </a:cubicBezTo>
+                <a:cubicBezTo>
+                  <a:pt x="9857058" y="13899"/>
+                  <a:pt x="10297509" y="7485"/>
+                  <a:pt x="10853928" y="0"/>
+                </a:cubicBezTo>
+                <a:cubicBezTo>
+                  <a:pt x="10854574" y="4451"/>
+                  <a:pt x="10854418" y="9226"/>
+                  <a:pt x="10853928" y="18288"/>
+                </a:cubicBezTo>
+                <a:cubicBezTo>
+                  <a:pt x="10691638" y="28522"/>
+                  <a:pt x="10574319" y="29578"/>
+                  <a:pt x="10392636" y="18288"/>
+                </a:cubicBezTo>
+                <a:cubicBezTo>
+                  <a:pt x="10210953" y="6998"/>
+                  <a:pt x="9836277" y="-16742"/>
+                  <a:pt x="9497187" y="18288"/>
+                </a:cubicBezTo>
+                <a:cubicBezTo>
+                  <a:pt x="9158097" y="53318"/>
+                  <a:pt x="9119479" y="30714"/>
+                  <a:pt x="8818817" y="18288"/>
+                </a:cubicBezTo>
+                <a:cubicBezTo>
+                  <a:pt x="8518155" y="5863"/>
+                  <a:pt x="8640037" y="6483"/>
+                  <a:pt x="8466064" y="18288"/>
+                </a:cubicBezTo>
+                <a:cubicBezTo>
+                  <a:pt x="8292091" y="30093"/>
+                  <a:pt x="7997656" y="18914"/>
+                  <a:pt x="7787693" y="18288"/>
+                </a:cubicBezTo>
+                <a:cubicBezTo>
+                  <a:pt x="7577730" y="17662"/>
+                  <a:pt x="7412468" y="21416"/>
+                  <a:pt x="7217862" y="18288"/>
+                </a:cubicBezTo>
+                <a:cubicBezTo>
+                  <a:pt x="7023256" y="15160"/>
+                  <a:pt x="6898018" y="14824"/>
+                  <a:pt x="6648031" y="18288"/>
+                </a:cubicBezTo>
+                <a:cubicBezTo>
+                  <a:pt x="6398044" y="21752"/>
+                  <a:pt x="6254402" y="38625"/>
+                  <a:pt x="6078200" y="18288"/>
+                </a:cubicBezTo>
+                <a:cubicBezTo>
+                  <a:pt x="5901998" y="-2049"/>
+                  <a:pt x="5622886" y="3213"/>
+                  <a:pt x="5508368" y="18288"/>
+                </a:cubicBezTo>
+                <a:cubicBezTo>
+                  <a:pt x="5393850" y="33363"/>
+                  <a:pt x="5036260" y="26830"/>
+                  <a:pt x="4721459" y="18288"/>
+                </a:cubicBezTo>
+                <a:cubicBezTo>
+                  <a:pt x="4406658" y="9746"/>
+                  <a:pt x="4239221" y="41551"/>
+                  <a:pt x="4043088" y="18288"/>
+                </a:cubicBezTo>
+                <a:cubicBezTo>
+                  <a:pt x="3846955" y="-4975"/>
+                  <a:pt x="3818802" y="34658"/>
+                  <a:pt x="3690336" y="18288"/>
+                </a:cubicBezTo>
+                <a:cubicBezTo>
+                  <a:pt x="3561870" y="1918"/>
+                  <a:pt x="3265491" y="42194"/>
+                  <a:pt x="3120504" y="18288"/>
+                </a:cubicBezTo>
+                <a:cubicBezTo>
+                  <a:pt x="2975517" y="-5618"/>
+                  <a:pt x="2720254" y="36673"/>
+                  <a:pt x="2333595" y="18288"/>
+                </a:cubicBezTo>
+                <a:cubicBezTo>
+                  <a:pt x="1946936" y="-97"/>
+                  <a:pt x="2097241" y="5776"/>
+                  <a:pt x="1872303" y="18288"/>
+                </a:cubicBezTo>
+                <a:cubicBezTo>
+                  <a:pt x="1647365" y="30800"/>
+                  <a:pt x="1282708" y="45380"/>
+                  <a:pt x="976854" y="18288"/>
+                </a:cubicBezTo>
+                <a:cubicBezTo>
+                  <a:pt x="671000" y="-8804"/>
+                  <a:pt x="408401" y="-12775"/>
+                  <a:pt x="0" y="18288"/>
+                </a:cubicBezTo>
+                <a:cubicBezTo>
+                  <a:pt x="-213" y="9468"/>
+                  <a:pt x="187" y="4459"/>
+                  <a:pt x="0" y="0"/>
+                </a:cubicBezTo>
+                <a:close/>
+              </a:path>
+              <a:path w="10853928" h="18288" stroke="0" extrusionOk="0">
+                <a:moveTo>
+                  <a:pt x="0" y="0"/>
+                </a:moveTo>
+                <a:cubicBezTo>
+                  <a:pt x="267322" y="15284"/>
+                  <a:pt x="415388" y="-21048"/>
+                  <a:pt x="569831" y="0"/>
+                </a:cubicBezTo>
+                <a:cubicBezTo>
+                  <a:pt x="724274" y="21048"/>
+                  <a:pt x="769333" y="-2353"/>
+                  <a:pt x="922584" y="0"/>
+                </a:cubicBezTo>
+                <a:cubicBezTo>
+                  <a:pt x="1075835" y="2353"/>
+                  <a:pt x="1399490" y="-145"/>
+                  <a:pt x="1818033" y="0"/>
+                </a:cubicBezTo>
+                <a:cubicBezTo>
+                  <a:pt x="2236576" y="145"/>
+                  <a:pt x="2145330" y="5482"/>
+                  <a:pt x="2387864" y="0"/>
+                </a:cubicBezTo>
+                <a:cubicBezTo>
+                  <a:pt x="2630398" y="-5482"/>
+                  <a:pt x="2793207" y="18487"/>
+                  <a:pt x="2957695" y="0"/>
+                </a:cubicBezTo>
+                <a:cubicBezTo>
+                  <a:pt x="3122183" y="-18487"/>
+                  <a:pt x="3579141" y="19003"/>
+                  <a:pt x="3853144" y="0"/>
+                </a:cubicBezTo>
+                <a:cubicBezTo>
+                  <a:pt x="4127147" y="-19003"/>
+                  <a:pt x="4209857" y="12211"/>
+                  <a:pt x="4314436" y="0"/>
+                </a:cubicBezTo>
+                <a:cubicBezTo>
+                  <a:pt x="4419015" y="-12211"/>
+                  <a:pt x="4762459" y="-17220"/>
+                  <a:pt x="5209885" y="0"/>
+                </a:cubicBezTo>
+                <a:cubicBezTo>
+                  <a:pt x="5657311" y="17220"/>
+                  <a:pt x="5692663" y="-3290"/>
+                  <a:pt x="6105335" y="0"/>
+                </a:cubicBezTo>
+                <a:cubicBezTo>
+                  <a:pt x="6518007" y="3290"/>
+                  <a:pt x="6455516" y="-5124"/>
+                  <a:pt x="6783705" y="0"/>
+                </a:cubicBezTo>
+                <a:cubicBezTo>
+                  <a:pt x="7111894" y="5124"/>
+                  <a:pt x="7441941" y="-17829"/>
+                  <a:pt x="7679154" y="0"/>
+                </a:cubicBezTo>
+                <a:cubicBezTo>
+                  <a:pt x="7916367" y="17829"/>
+                  <a:pt x="8102967" y="-24363"/>
+                  <a:pt x="8248985" y="0"/>
+                </a:cubicBezTo>
+                <a:cubicBezTo>
+                  <a:pt x="8395003" y="24363"/>
+                  <a:pt x="8552393" y="25505"/>
+                  <a:pt x="8818817" y="0"/>
+                </a:cubicBezTo>
+                <a:cubicBezTo>
+                  <a:pt x="9085241" y="-25505"/>
+                  <a:pt x="9411308" y="38000"/>
+                  <a:pt x="9605726" y="0"/>
+                </a:cubicBezTo>
+                <a:cubicBezTo>
+                  <a:pt x="9800144" y="-38000"/>
+                  <a:pt x="10006468" y="-25741"/>
+                  <a:pt x="10175558" y="0"/>
+                </a:cubicBezTo>
+                <a:cubicBezTo>
+                  <a:pt x="10344648" y="25741"/>
+                  <a:pt x="10696282" y="695"/>
+                  <a:pt x="10853928" y="0"/>
+                </a:cubicBezTo>
+                <a:cubicBezTo>
+                  <a:pt x="10853521" y="8690"/>
+                  <a:pt x="10853774" y="14141"/>
+                  <a:pt x="10853928" y="18288"/>
+                </a:cubicBezTo>
+                <a:cubicBezTo>
+                  <a:pt x="10608124" y="24255"/>
+                  <a:pt x="10343415" y="22307"/>
+                  <a:pt x="10067018" y="18288"/>
+                </a:cubicBezTo>
+                <a:cubicBezTo>
+                  <a:pt x="9790621" y="14270"/>
+                  <a:pt x="9843266" y="3564"/>
+                  <a:pt x="9714266" y="18288"/>
+                </a:cubicBezTo>
+                <a:cubicBezTo>
+                  <a:pt x="9585266" y="33012"/>
+                  <a:pt x="9379484" y="1875"/>
+                  <a:pt x="9252974" y="18288"/>
+                </a:cubicBezTo>
+                <a:cubicBezTo>
+                  <a:pt x="9126464" y="34701"/>
+                  <a:pt x="8580678" y="-4904"/>
+                  <a:pt x="8357525" y="18288"/>
+                </a:cubicBezTo>
+                <a:cubicBezTo>
+                  <a:pt x="8134372" y="41480"/>
+                  <a:pt x="7903199" y="26458"/>
+                  <a:pt x="7679154" y="18288"/>
+                </a:cubicBezTo>
+                <a:cubicBezTo>
+                  <a:pt x="7455109" y="10118"/>
+                  <a:pt x="7435944" y="27109"/>
+                  <a:pt x="7217862" y="18288"/>
+                </a:cubicBezTo>
+                <a:cubicBezTo>
+                  <a:pt x="6999780" y="9467"/>
+                  <a:pt x="6680409" y="18985"/>
+                  <a:pt x="6539492" y="18288"/>
+                </a:cubicBezTo>
+                <a:cubicBezTo>
+                  <a:pt x="6398575" y="17592"/>
+                  <a:pt x="6312077" y="33018"/>
+                  <a:pt x="6186739" y="18288"/>
+                </a:cubicBezTo>
+                <a:cubicBezTo>
+                  <a:pt x="6061401" y="3558"/>
+                  <a:pt x="5947033" y="12075"/>
+                  <a:pt x="5833986" y="18288"/>
+                </a:cubicBezTo>
+                <a:cubicBezTo>
+                  <a:pt x="5720939" y="24501"/>
+                  <a:pt x="5482226" y="8586"/>
+                  <a:pt x="5155616" y="18288"/>
+                </a:cubicBezTo>
+                <a:cubicBezTo>
+                  <a:pt x="4829006" y="27991"/>
+                  <a:pt x="4841274" y="29316"/>
+                  <a:pt x="4694324" y="18288"/>
+                </a:cubicBezTo>
+                <a:cubicBezTo>
+                  <a:pt x="4547374" y="7260"/>
+                  <a:pt x="4077675" y="7013"/>
+                  <a:pt x="3907414" y="18288"/>
+                </a:cubicBezTo>
+                <a:cubicBezTo>
+                  <a:pt x="3737153" y="29564"/>
+                  <a:pt x="3538393" y="21630"/>
+                  <a:pt x="3446122" y="18288"/>
+                </a:cubicBezTo>
+                <a:cubicBezTo>
+                  <a:pt x="3353851" y="14946"/>
+                  <a:pt x="2990320" y="-8091"/>
+                  <a:pt x="2659212" y="18288"/>
+                </a:cubicBezTo>
+                <a:cubicBezTo>
+                  <a:pt x="2328104" y="44667"/>
+                  <a:pt x="2427653" y="9607"/>
+                  <a:pt x="2306460" y="18288"/>
+                </a:cubicBezTo>
+                <a:cubicBezTo>
+                  <a:pt x="2185267" y="26969"/>
+                  <a:pt x="1719763" y="3717"/>
+                  <a:pt x="1519550" y="18288"/>
+                </a:cubicBezTo>
+                <a:cubicBezTo>
+                  <a:pt x="1319337" y="32860"/>
+                  <a:pt x="1167371" y="17040"/>
+                  <a:pt x="1058258" y="18288"/>
+                </a:cubicBezTo>
+                <a:cubicBezTo>
+                  <a:pt x="949145" y="19536"/>
+                  <a:pt x="780234" y="31447"/>
+                  <a:pt x="705505" y="18288"/>
+                </a:cubicBezTo>
+                <a:cubicBezTo>
+                  <a:pt x="630776" y="5129"/>
+                  <a:pt x="215796" y="30056"/>
+                  <a:pt x="0" y="18288"/>
+                </a:cubicBezTo>
+                <a:cubicBezTo>
+                  <a:pt x="-53" y="11301"/>
+                  <a:pt x="-649" y="7756"/>
+                  <a:pt x="0" y="0"/>
+                </a:cubicBezTo>
+                <a:close/>
+              </a:path>
+            </a:pathLst>
+          </a:custGeom>
+          <a:solidFill>
+            <a:schemeClr val="accent2"/>
+          </a:solidFill>
+          <a:ln w="41275" cap="rnd">
+            <a:solidFill>
+              <a:schemeClr val="accent2"/>
+            </a:solidFill>
+            <a:round/>
+            <a:extLst>
+              <a:ext uri="{C807C97D-BFC1-408E-A445-0C87EB9F89A2}">
+                <ask:lineSketchStyleProps xmlns:ask="http://schemas.microsoft.com/office/drawing/2018/sketchyshapes" sd="1219033472">
+                  <a:prstGeom prst="rect">
+                    <a:avLst/>
+                  </a:prstGeom>
+                  <ask:type>
+                    <ask:lineSketchFreehand/>
+                  </ask:type>
+                </ask:lineSketchStyleProps>
+              </a:ext>
+            </a:extLst>
+          </a:ln>
+        </p:spPr>
+        <p:style>
+          <a:lnRef idx="2">
+            <a:schemeClr val="accent1">
+              <a:shade val="50000"/>
+            </a:schemeClr>
+          </a:lnRef>
+          <a:fillRef idx="1">
+            <a:schemeClr val="accent1"/>
+          </a:fillRef>
+          <a:effectRef idx="0">
+            <a:schemeClr val="accent1"/>
+          </a:effectRef>
+          <a:fontRef idx="minor">
+            <a:schemeClr val="lt1"/>
+          </a:fontRef>
+        </p:style>
+        <p:txBody>
+          <a:bodyPr rtlCol="0" anchor="ctr"/>
+          <a:lstStyle/>
+          <a:p>
+            <a:pPr algn="ctr"/>
+            <a:endParaRPr lang="en-US"/>
+          </a:p>
+        </p:txBody>
+      </p:sp>
+      <p:sp>
+        <p:nvSpPr>
+          <p:cNvPr id="3" name="Content Placeholder 2">
+            <a:extLst>
+              <a:ext uri="{FF2B5EF4-FFF2-40B4-BE49-F238E27FC236}">
+                <a16:creationId xmlns:a16="http://schemas.microsoft.com/office/drawing/2014/main" id="{76AA1C5F-B7ED-DCF6-FDB7-6599E320465B}"/>
+              </a:ext>
+            </a:extLst>
+          </p:cNvPr>
+          <p:cNvSpPr>
+            <a:spLocks noGrp="1"/>
+          </p:cNvSpPr>
+          <p:nvPr>
+            <p:ph idx="1"/>
+          </p:nvPr>
+        </p:nvSpPr>
+        <p:spPr>
+          <a:xfrm>
+            <a:off x="838200" y="1929384"/>
+            <a:ext cx="10515600" cy="4251960"/>
+          </a:xfrm>
+        </p:spPr>
+        <p:txBody>
+          <a:bodyPr>
+            <a:normAutofit/>
+          </a:bodyPr>
+          <a:lstStyle/>
+          <a:p>
+            <a:pPr lvl="1"/>
+            <a:endParaRPr lang="en-US" sz="1000" dirty="0"/>
+          </a:p>
+          <a:p>
+            <a:endParaRPr lang="en-US" sz="1800" dirty="0"/>
+          </a:p>
+          <a:p>
+            <a:endParaRPr lang="en-US" sz="2200" dirty="0"/>
+          </a:p>
+          <a:p>
+            <a:pPr lvl="1"/>
+            <a:endParaRPr lang="en-US" sz="1800" dirty="0"/>
+          </a:p>
+        </p:txBody>
+      </p:sp>
+      <p:pic>
+        <p:nvPicPr>
+          <p:cNvPr id="1026" name="Picture 2" descr="Power Fx reverse search.">
+            <a:extLst>
+              <a:ext uri="{FF2B5EF4-FFF2-40B4-BE49-F238E27FC236}">
+                <a16:creationId xmlns:a16="http://schemas.microsoft.com/office/drawing/2014/main" id="{9761B525-923F-99B6-7D93-0547955334AC}"/>
+              </a:ext>
+            </a:extLst>
+          </p:cNvPr>
+          <p:cNvPicPr>
+            <a:picLocks noChangeAspect="1" noChangeArrowheads="1"/>
+          </p:cNvPicPr>
+          <p:nvPr/>
+        </p:nvPicPr>
+        <p:blipFill>
+          <a:blip r:embed="rId3">
+            <a:extLst>
+              <a:ext uri="{28A0092B-C50C-407E-A947-70E740481C1C}">
+                <a14:useLocalDpi xmlns:a14="http://schemas.microsoft.com/office/drawing/2010/main" val="0"/>
+              </a:ext>
+            </a:extLst>
+          </a:blip>
+          <a:srcRect/>
+          <a:stretch>
+            <a:fillRect/>
+          </a:stretch>
+        </p:blipFill>
+        <p:spPr bwMode="auto">
+          <a:xfrm>
+            <a:off x="1363980" y="2179011"/>
+            <a:ext cx="8313420" cy="3120984"/>
+          </a:xfrm>
+          <a:prstGeom prst="rect">
+            <a:avLst/>
+          </a:prstGeom>
+          <a:noFill/>
+          <a:extLst>
+            <a:ext uri="{909E8E84-426E-40DD-AFC4-6F175D3DCCD1}">
+              <a14:hiddenFill xmlns:a14="http://schemas.microsoft.com/office/drawing/2010/main">
+                <a:solidFill>
+                  <a:srgbClr val="FFFFFF"/>
+                </a:solidFill>
+              </a14:hiddenFill>
+            </a:ext>
+          </a:extLst>
+        </p:spPr>
+      </p:pic>
+    </p:spTree>
+    <p:extLst>
+      <p:ext uri="{BB962C8B-B14F-4D97-AF65-F5344CB8AC3E}">
+        <p14:creationId xmlns:p14="http://schemas.microsoft.com/office/powerpoint/2010/main" val="276874375"/>
+      </p:ext>
+    </p:extLst>
+  </p:cSld>
+  <p:clrMapOvr>
+    <a:masterClrMapping/>
+  </p:clrMapOvr>
+</p:sld>
+</file>
+
+<file path=ppt/slides/slide11.xml><?xml version="1.0" encoding="utf-8"?>
+<p:sld xmlns:a="http://schemas.openxmlformats.org/drawingml/2006/main" xmlns:r="http://schemas.openxmlformats.org/officeDocument/2006/relationships" xmlns:p="http://schemas.openxmlformats.org/presentationml/2006/main">
+  <p:cSld>
     <p:spTree>
       <p:nvGrpSpPr>
         <p:cNvPr id="1" name=""/>
@@ -8425,7 +9679,7 @@
 </p:sld>
 </file>
 
-<file path=ppt/slides/slide11.xml><?xml version="1.0" encoding="utf-8"?>
+<file path=ppt/slides/slide12.xml><?xml version="1.0" encoding="utf-8"?>
 <p:sld xmlns:a="http://schemas.openxmlformats.org/drawingml/2006/main" xmlns:r="http://schemas.openxmlformats.org/officeDocument/2006/relationships" xmlns:p="http://schemas.openxmlformats.org/presentationml/2006/main">
   <p:cSld>
     <p:bg>
@@ -9269,7 +10523,7 @@
 </p:sld>
 </file>
 
-<file path=ppt/slides/slide12.xml><?xml version="1.0" encoding="utf-8"?>
+<file path=ppt/slides/slide13.xml><?xml version="1.0" encoding="utf-8"?>
 <p:sld xmlns:a="http://schemas.openxmlformats.org/drawingml/2006/main" xmlns:r="http://schemas.openxmlformats.org/officeDocument/2006/relationships" xmlns:p="http://schemas.openxmlformats.org/presentationml/2006/main">
   <p:cSld>
     <p:spTree>
@@ -9358,7 +10612,7 @@
 </p:sld>
 </file>
 
-<file path=ppt/slides/slide13.xml><?xml version="1.0" encoding="utf-8"?>
+<file path=ppt/slides/slide14.xml><?xml version="1.0" encoding="utf-8"?>
 <p:sld xmlns:a="http://schemas.openxmlformats.org/drawingml/2006/main" xmlns:r="http://schemas.openxmlformats.org/officeDocument/2006/relationships" xmlns:p="http://schemas.openxmlformats.org/presentationml/2006/main">
   <p:cSld>
     <p:bg>
@@ -10209,7 +11463,7 @@
 </p:sld>
 </file>
 
-<file path=ppt/slides/slide14.xml><?xml version="1.0" encoding="utf-8"?>
+<file path=ppt/slides/slide15.xml><?xml version="1.0" encoding="utf-8"?>
 <p:sld xmlns:a="http://schemas.openxmlformats.org/drawingml/2006/main" xmlns:r="http://schemas.openxmlformats.org/officeDocument/2006/relationships" xmlns:p="http://schemas.openxmlformats.org/presentationml/2006/main">
   <p:cSld>
     <p:bg>
@@ -11041,7 +12295,7 @@
 </p:sld>
 </file>
 
-<file path=ppt/slides/slide15.xml><?xml version="1.0" encoding="utf-8"?>
+<file path=ppt/slides/slide16.xml><?xml version="1.0" encoding="utf-8"?>
 <p:sld xmlns:a="http://schemas.openxmlformats.org/drawingml/2006/main" xmlns:r="http://schemas.openxmlformats.org/officeDocument/2006/relationships" xmlns:p="http://schemas.openxmlformats.org/presentationml/2006/main">
   <p:cSld>
     <p:bg>
@@ -11873,7 +13127,7 @@
 </p:sld>
 </file>
 
-<file path=ppt/slides/slide16.xml><?xml version="1.0" encoding="utf-8"?>
+<file path=ppt/slides/slide17.xml><?xml version="1.0" encoding="utf-8"?>
 <p:sld xmlns:a="http://schemas.openxmlformats.org/drawingml/2006/main" xmlns:r="http://schemas.openxmlformats.org/officeDocument/2006/relationships" xmlns:p="http://schemas.openxmlformats.org/presentationml/2006/main">
   <p:cSld>
     <p:spTree>
@@ -11962,7 +13216,7 @@
 </p:sld>
 </file>
 
-<file path=ppt/slides/slide17.xml><?xml version="1.0" encoding="utf-8"?>
+<file path=ppt/slides/slide18.xml><?xml version="1.0" encoding="utf-8"?>
 <p:sld xmlns:a="http://schemas.openxmlformats.org/drawingml/2006/main" xmlns:r="http://schemas.openxmlformats.org/officeDocument/2006/relationships" xmlns:p="http://schemas.openxmlformats.org/presentationml/2006/main">
   <p:cSld>
     <p:bg>
@@ -15790,15 +17044,7 @@
             <a:pPr lvl="2"/>
             <a:r>
               <a:rPr lang="en-US" sz="1000" dirty="0"/>
-              <a:t>Logic that specifies that customers with certain amount of purchases get a discount is very </a:t>
-            </a:r>
-            <a:r>
-              <a:rPr lang="en-US" sz="1000" dirty="0" err="1"/>
-              <a:t>speciifc</a:t>
-            </a:r>
-            <a:r>
-              <a:rPr lang="en-US" sz="1000" dirty="0"/>
-              <a:t>.</a:t>
+              <a:t>Logic that specifies that customers with certain number of purchases get a discount is very specific.</a:t>
             </a:r>
           </a:p>
           <a:p>
@@ -17918,33 +19164,50 @@
           <a:lstStyle/>
           <a:p>
             <a:r>
-              <a:rPr lang="en-US"/>
+              <a:rPr lang="en-US" dirty="0"/>
               <a:t>Business user friendly</a:t>
             </a:r>
           </a:p>
           <a:p>
             <a:r>
-              <a:rPr lang="en-US"/>
+              <a:rPr lang="en-US" dirty="0"/>
               <a:t>Open sourced by Microsoft</a:t>
             </a:r>
           </a:p>
           <a:p>
             <a:r>
-              <a:rPr lang="en-US"/>
+              <a:rPr lang="en-US" dirty="0"/>
               <a:t>Similar to Excel formulas</a:t>
             </a:r>
           </a:p>
           <a:p>
             <a:r>
-              <a:rPr lang="en-US"/>
+              <a:rPr lang="en-US" dirty="0"/>
               <a:t>Use in many parts of the Power Platform</a:t>
             </a:r>
           </a:p>
           <a:p>
             <a:pPr lvl="1"/>
             <a:r>
-              <a:rPr lang="en-US"/>
-              <a:t>Many Experts, Tutorials, Articles, etc</a:t>
+              <a:rPr lang="en-US" dirty="0"/>
+              <a:t>Many Experts, Tutorials, Articles, </a:t>
+            </a:r>
+            <a:r>
+              <a:rPr lang="en-US" dirty="0" err="1"/>
+              <a:t>etc</a:t>
+            </a:r>
+            <a:endParaRPr lang="en-US" dirty="0"/>
+          </a:p>
+          <a:p>
+            <a:r>
+              <a:rPr lang="en-US" dirty="0">
+                <a:hlinkClick r:id="rId3"/>
+              </a:rPr>
+              <a:t>https://learn.microsoft.com/en-us/power-platform/power-fx/overview</a:t>
+            </a:r>
+            <a:r>
+              <a:rPr lang="en-US" dirty="0"/>
+              <a:t> </a:t>
             </a:r>
           </a:p>
         </p:txBody>

</xml_diff>